<commit_message>
Remove all mentions of 'free'
Reword copy, meta, schema, FAQ, manifest and README; regenerate example
video (narration no longer says it's free) and social share images.

Co-Authored-By: Claude Opus 5.5 <noreply@anthropic.com>
Claude-Session: https://claude.ai/code/session_01Sa8kFYJJaPTbqgpE8y53yo
</commit_message>
<xml_diff>
--- a/assets/example/example-deck.pptx
+++ b/assets/example/example-deck.pptx
@@ -716,7 +716,7 @@
           <a:lstStyle/>
           <a:p>
             <a:r>
-              <a:t>Everything runs in your browser. Nothing is uploaded, so your slides never leave your device. There is no sign-up and no watermark, and it is free.</a:t>
+              <a:t>Everything runs in your browser. Nothing is uploaded, so your slides never leave your device. There is no sign-up and no watermark.</a:t>
             </a:r>
           </a:p>
         </p:txBody>
@@ -3967,7 +3967,7 @@
                 </a:solidFill>
                 <a:latin typeface="Inter"/>
               </a:rPr>
-              <a:t>FREE · PRIVATE · ONLINE</a:t>
+              <a:t>PRIVATE · ONLINE · NO UPLOAD</a:t>
             </a:r>
           </a:p>
         </p:txBody>
@@ -6266,139 +6266,7 @@
       </p:sp>
       <p:sp>
         <p:nvSpPr>
-          <p:cNvPr id="18" name="Rounded Rectangle 17"/>
-          <p:cNvSpPr/>
-          <p:nvPr/>
-        </p:nvSpPr>
-        <p:spPr>
-          <a:xfrm>
-            <a:off x="6208776" y="4023360"/>
-            <a:ext cx="5431536" cy="1325880"/>
-          </a:xfrm>
-          <a:prstGeom prst="roundRect">
-            <a:avLst>
-              <a:gd name="adj" fmla="val 17241"/>
-            </a:avLst>
-          </a:prstGeom>
-          <a:solidFill>
-            <a:srgbClr val="FFFFFF"/>
-          </a:solidFill>
-          <a:ln w="15875">
-            <a:solidFill>
-              <a:srgbClr val="E1DEF1"/>
-            </a:solidFill>
-          </a:ln>
-        </p:spPr>
-        <p:txBody>
-          <a:bodyPr rtlCol="0" anchor="ctr"/>
-          <a:lstStyle/>
-          <a:p>
-            <a:pPr algn="ctr"/>
-          </a:p>
-        </p:txBody>
-      </p:sp>
-      <p:sp>
-        <p:nvSpPr>
-          <p:cNvPr id="19" name="Oval 18"/>
-          <p:cNvSpPr/>
-          <p:nvPr/>
-        </p:nvSpPr>
-        <p:spPr>
-          <a:xfrm>
-            <a:off x="6620256" y="4389120"/>
-            <a:ext cx="594360" cy="594360"/>
-          </a:xfrm>
-          <a:prstGeom prst="ellipse">
-            <a:avLst/>
-          </a:prstGeom>
-          <a:solidFill>
-            <a:srgbClr val="1FBF8F"/>
-          </a:solidFill>
-          <a:ln>
-            <a:noFill/>
-          </a:ln>
-        </p:spPr>
-        <p:txBody>
-          <a:bodyPr rtlCol="0" anchor="ctr"/>
-          <a:lstStyle/>
-          <a:p>
-            <a:pPr algn="ctr"/>
-          </a:p>
-        </p:txBody>
-      </p:sp>
-      <p:sp>
-        <p:nvSpPr>
-          <p:cNvPr id="20" name="TextBox 19"/>
-          <p:cNvSpPr txBox="1"/>
-          <p:nvPr/>
-        </p:nvSpPr>
-        <p:spPr>
-          <a:xfrm>
-            <a:off x="6620256" y="4389120"/>
-            <a:ext cx="594360" cy="594360"/>
-          </a:xfrm>
-          <a:prstGeom prst="rect">
-            <a:avLst/>
-          </a:prstGeom>
-          <a:noFill/>
-        </p:spPr>
-        <p:txBody>
-          <a:bodyPr wrap="square" anchor="ctr" lIns="0" rIns="0" tIns="0" bIns="0">
-            <a:spAutoFit/>
-          </a:bodyPr>
-          <a:lstStyle/>
-          <a:p>
-            <a:pPr algn="ctr"/>
-            <a:r>
-              <a:rPr sz="2400" b="1">
-                <a:solidFill>
-                  <a:srgbClr val="FFFFFF"/>
-                </a:solidFill>
-                <a:latin typeface="Inter"/>
-              </a:rPr>
-              <a:t>✓</a:t>
-            </a:r>
-          </a:p>
-        </p:txBody>
-      </p:sp>
-      <p:sp>
-        <p:nvSpPr>
-          <p:cNvPr id="21" name="TextBox 20"/>
-          <p:cNvSpPr txBox="1"/>
-          <p:nvPr/>
-        </p:nvSpPr>
-        <p:spPr>
-          <a:xfrm>
-            <a:off x="7488936" y="4023360"/>
-            <a:ext cx="3877056" cy="1325880"/>
-          </a:xfrm>
-          <a:prstGeom prst="rect">
-            <a:avLst/>
-          </a:prstGeom>
-          <a:noFill/>
-        </p:spPr>
-        <p:txBody>
-          <a:bodyPr wrap="square" anchor="ctr" lIns="0" rIns="0" tIns="0" bIns="0">
-            <a:spAutoFit/>
-          </a:bodyPr>
-          <a:lstStyle/>
-          <a:p>
-            <a:pPr algn="l"/>
-            <a:r>
-              <a:rPr sz="2600" b="1">
-                <a:solidFill>
-                  <a:srgbClr val="0E1330"/>
-                </a:solidFill>
-                <a:latin typeface="Inter"/>
-              </a:rPr>
-              <a:t>Free to use</a:t>
-            </a:r>
-          </a:p>
-        </p:txBody>
-      </p:sp>
-      <p:sp>
-        <p:nvSpPr>
-          <p:cNvPr id="22" name="TextBox 21"/>
+          <p:cNvPr id="18" name="TextBox 17"/>
           <p:cNvSpPr txBox="1"/>
           <p:nvPr/>
         </p:nvSpPr>
@@ -6433,7 +6301,7 @@
       </p:sp>
       <p:sp>
         <p:nvSpPr>
-          <p:cNvPr id="23" name="TextBox 22"/>
+          <p:cNvPr id="19" name="TextBox 18"/>
           <p:cNvSpPr txBox="1"/>
           <p:nvPr/>
         </p:nvSpPr>

</xml_diff>